<commit_message>
docs: add team info - Inference TimeOut (Asha Jyothi Boddu & Sai Srinidhi Repala). PPT slide 1 team box added; custom doc cover page team box added; PDF regenerated.
</commit_message>
<xml_diff>
--- a/VidyutDrishti_Pitch.pptx
+++ b/VidyutDrishti_Pitch.pptx
@@ -3530,14 +3530,14 @@
       </p:sp>
       <p:sp>
         <p:nvSpPr>
-          <p:cNvPr id="12" name="TextBox 11"/>
-          <p:cNvSpPr txBox="1"/>
-          <p:nvPr/>
-        </p:nvSpPr>
-        <p:spPr>
-          <a:xfrm>
-            <a:off x="731520" y="6309360"/>
-            <a:ext cx="3657600" cy="365760"/>
+          <p:cNvPr id="13" name="TextBox 12"/>
+          <p:cNvSpPr txBox="1"/>
+          <p:nvPr/>
+        </p:nvSpPr>
+        <p:spPr>
+          <a:xfrm>
+            <a:off x="4572000" y="6080760"/>
+            <a:ext cx="3657600" cy="274320"/>
           </a:xfrm>
           <a:prstGeom prst="rect">
             <a:avLst/>
@@ -3556,27 +3556,27 @@
               </a:lnSpc>
             </a:pPr>
             <a:r>
-              <a:rPr sz="1200" b="0">
-                <a:solidFill>
-                  <a:srgbClr val="FFFFFF"/>
+              <a:rPr sz="900" b="1">
+                <a:solidFill>
+                  <a:srgbClr val="B45309"/>
                 </a:solidFill>
                 <a:latin typeface="Calibri"/>
               </a:rPr>
-              <a:t>[Team Name] · [Member 1] · [Member 2]</a:t>
-            </a:r>
-          </a:p>
-        </p:txBody>
-      </p:sp>
-      <p:sp>
-        <p:nvSpPr>
-          <p:cNvPr id="13" name="TextBox 12"/>
-          <p:cNvSpPr txBox="1"/>
-          <p:nvPr/>
-        </p:nvSpPr>
-        <p:spPr>
-          <a:xfrm>
-            <a:off x="4572000" y="6080760"/>
-            <a:ext cx="3657600" cy="274320"/>
+              <a:t>PROTOTYPE</a:t>
+            </a:r>
+          </a:p>
+        </p:txBody>
+      </p:sp>
+      <p:sp>
+        <p:nvSpPr>
+          <p:cNvPr id="14" name="TextBox 13"/>
+          <p:cNvSpPr txBox="1"/>
+          <p:nvPr/>
+        </p:nvSpPr>
+        <p:spPr>
+          <a:xfrm>
+            <a:off x="4572000" y="6309360"/>
+            <a:ext cx="3657600" cy="365760"/>
           </a:xfrm>
           <a:prstGeom prst="rect">
             <a:avLst/>
@@ -3595,27 +3595,27 @@
               </a:lnSpc>
             </a:pPr>
             <a:r>
-              <a:rPr sz="900" b="1">
-                <a:solidFill>
-                  <a:srgbClr val="B45309"/>
+              <a:rPr sz="1200" b="0">
+                <a:solidFill>
+                  <a:srgbClr val="FFFFFF"/>
                 </a:solidFill>
                 <a:latin typeface="Calibri"/>
               </a:rPr>
-              <a:t>PROTOTYPE</a:t>
-            </a:r>
-          </a:p>
-        </p:txBody>
-      </p:sp>
-      <p:sp>
-        <p:nvSpPr>
-          <p:cNvPr id="14" name="TextBox 13"/>
-          <p:cNvSpPr txBox="1"/>
-          <p:nvPr/>
-        </p:nvSpPr>
-        <p:spPr>
-          <a:xfrm>
-            <a:off x="4572000" y="6309360"/>
-            <a:ext cx="3657600" cy="365760"/>
+              <a:t>Live · Docker Compose · 7 modules</a:t>
+            </a:r>
+          </a:p>
+        </p:txBody>
+      </p:sp>
+      <p:sp>
+        <p:nvSpPr>
+          <p:cNvPr id="15" name="TextBox 14"/>
+          <p:cNvSpPr txBox="1"/>
+          <p:nvPr/>
+        </p:nvSpPr>
+        <p:spPr>
+          <a:xfrm>
+            <a:off x="8229600" y="6080760"/>
+            <a:ext cx="3657600" cy="274320"/>
           </a:xfrm>
           <a:prstGeom prst="rect">
             <a:avLst/>
@@ -3634,27 +3634,27 @@
               </a:lnSpc>
             </a:pPr>
             <a:r>
-              <a:rPr sz="1200" b="0">
-                <a:solidFill>
-                  <a:srgbClr val="FFFFFF"/>
+              <a:rPr sz="900" b="1">
+                <a:solidFill>
+                  <a:srgbClr val="B45309"/>
                 </a:solidFill>
                 <a:latin typeface="Calibri"/>
               </a:rPr>
-              <a:t>Live · Docker Compose · 7 modules</a:t>
-            </a:r>
-          </a:p>
-        </p:txBody>
-      </p:sp>
-      <p:sp>
-        <p:nvSpPr>
-          <p:cNvPr id="15" name="TextBox 14"/>
-          <p:cNvSpPr txBox="1"/>
-          <p:nvPr/>
-        </p:nvSpPr>
-        <p:spPr>
-          <a:xfrm>
-            <a:off x="8229600" y="6080760"/>
-            <a:ext cx="3657600" cy="274320"/>
+              <a:t>DEMO VIDEO</a:t>
+            </a:r>
+          </a:p>
+        </p:txBody>
+      </p:sp>
+      <p:sp>
+        <p:nvSpPr>
+          <p:cNvPr id="16" name="TextBox 15"/>
+          <p:cNvSpPr txBox="1"/>
+          <p:nvPr/>
+        </p:nvSpPr>
+        <p:spPr>
+          <a:xfrm>
+            <a:off x="8229600" y="6309360"/>
+            <a:ext cx="3931920" cy="365760"/>
           </a:xfrm>
           <a:prstGeom prst="rect">
             <a:avLst/>
@@ -3673,52 +3673,169 @@
               </a:lnSpc>
             </a:pPr>
             <a:r>
-              <a:rPr sz="900" b="1">
-                <a:solidFill>
-                  <a:srgbClr val="B45309"/>
+              <a:rPr sz="1100" b="0">
+                <a:solidFill>
+                  <a:srgbClr val="FFFFFF"/>
                 </a:solidFill>
                 <a:latin typeface="Calibri"/>
               </a:rPr>
-              <a:t>DEMO VIDEO</a:t>
-            </a:r>
-          </a:p>
-        </p:txBody>
-      </p:sp>
-      <p:sp>
-        <p:nvSpPr>
-          <p:cNvPr id="16" name="TextBox 15"/>
-          <p:cNvSpPr txBox="1"/>
-          <p:nvPr/>
-        </p:nvSpPr>
-        <p:spPr>
-          <a:xfrm>
-            <a:off x="8229600" y="6309360"/>
-            <a:ext cx="3931920" cy="365760"/>
-          </a:xfrm>
-          <a:prstGeom prst="rect">
-            <a:avLst/>
-          </a:prstGeom>
-          <a:noFill/>
-        </p:spPr>
-        <p:txBody>
-          <a:bodyPr wrap="square" lIns="45720" rIns="45720" tIns="18288" bIns="18288" anchor="t">
-            <a:spAutoFit/>
-          </a:bodyPr>
-          <a:lstStyle/>
-          <a:p>
-            <a:pPr algn="l">
-              <a:lnSpc>
-                <a:spcPct val="115000"/>
-              </a:lnSpc>
-            </a:pPr>
-            <a:r>
-              <a:rPr sz="1100" b="0">
-                <a:solidFill>
-                  <a:srgbClr val="FFFFFF"/>
-                </a:solidFill>
-                <a:latin typeface="Calibri"/>
-              </a:rPr>
               <a:t>https://drive.google.com/file/d/1LOgpMxeu2LzAK52B-go-8gtAn6rHe1Eu/view?usp=sharing</a:t>
+            </a:r>
+          </a:p>
+        </p:txBody>
+      </p:sp>
+      <p:sp>
+        <p:nvSpPr>
+          <p:cNvPr id="17" name="Rectangle 16"/>
+          <p:cNvSpPr/>
+          <p:nvPr/>
+        </p:nvSpPr>
+        <p:spPr>
+          <a:xfrm>
+            <a:off x="365760" y="5440680"/>
+            <a:ext cx="4754880" cy="658368"/>
+          </a:xfrm>
+          <a:prstGeom prst="rect">
+            <a:avLst/>
+          </a:prstGeom>
+          <a:solidFill>
+            <a:srgbClr val="DBEAFE"/>
+          </a:solidFill>
+          <a:ln>
+            <a:solidFill>
+              <a:srgbClr val="1E40AF"/>
+            </a:solidFill>
+          </a:ln>
+        </p:spPr>
+        <p:style>
+          <a:lnRef idx="1">
+            <a:schemeClr val="accent1"/>
+          </a:lnRef>
+          <a:fillRef idx="3">
+            <a:schemeClr val="accent1"/>
+          </a:fillRef>
+          <a:effectRef idx="2">
+            <a:schemeClr val="accent1"/>
+          </a:effectRef>
+          <a:fontRef idx="minor">
+            <a:schemeClr val="lt1"/>
+          </a:fontRef>
+        </p:style>
+        <p:txBody>
+          <a:bodyPr rtlCol="0" anchor="ctr"/>
+          <a:lstStyle/>
+          <a:p>
+            <a:pPr algn="ctr"/>
+          </a:p>
+        </p:txBody>
+      </p:sp>
+      <p:sp>
+        <p:nvSpPr>
+          <p:cNvPr id="18" name="Rectangle 17"/>
+          <p:cNvSpPr/>
+          <p:nvPr/>
+        </p:nvSpPr>
+        <p:spPr>
+          <a:xfrm>
+            <a:off x="365760" y="5440680"/>
+            <a:ext cx="64008" cy="658368"/>
+          </a:xfrm>
+          <a:prstGeom prst="rect">
+            <a:avLst/>
+          </a:prstGeom>
+          <a:solidFill>
+            <a:srgbClr val="1E40AF"/>
+          </a:solidFill>
+          <a:ln>
+            <a:noFill/>
+          </a:ln>
+        </p:spPr>
+        <p:style>
+          <a:lnRef idx="1">
+            <a:schemeClr val="accent1"/>
+          </a:lnRef>
+          <a:fillRef idx="3">
+            <a:schemeClr val="accent1"/>
+          </a:fillRef>
+          <a:effectRef idx="2">
+            <a:schemeClr val="accent1"/>
+          </a:effectRef>
+          <a:fontRef idx="minor">
+            <a:schemeClr val="lt1"/>
+          </a:fontRef>
+        </p:style>
+        <p:txBody>
+          <a:bodyPr rtlCol="0" anchor="ctr"/>
+          <a:lstStyle/>
+          <a:p>
+            <a:pPr algn="ctr"/>
+          </a:p>
+        </p:txBody>
+      </p:sp>
+      <p:sp>
+        <p:nvSpPr>
+          <p:cNvPr id="19" name="TextBox 18"/>
+          <p:cNvSpPr txBox="1"/>
+          <p:nvPr/>
+        </p:nvSpPr>
+        <p:spPr>
+          <a:xfrm>
+            <a:off x="493776" y="5495544"/>
+            <a:ext cx="4572000" cy="256032"/>
+          </a:xfrm>
+          <a:prstGeom prst="rect">
+            <a:avLst/>
+          </a:prstGeom>
+          <a:noFill/>
+        </p:spPr>
+        <p:txBody>
+          <a:bodyPr wrap="square">
+            <a:spAutoFit/>
+          </a:bodyPr>
+          <a:lstStyle/>
+          <a:p>
+            <a:pPr algn="l"/>
+            <a:r>
+              <a:rPr b="1" i="0" sz="1100">
+                <a:solidFill>
+                  <a:srgbClr val="1E40AF"/>
+                </a:solidFill>
+              </a:rPr>
+              <a:t>Team: Inference TimeOut</a:t>
+            </a:r>
+          </a:p>
+        </p:txBody>
+      </p:sp>
+      <p:sp>
+        <p:nvSpPr>
+          <p:cNvPr id="20" name="TextBox 19"/>
+          <p:cNvSpPr txBox="1"/>
+          <p:nvPr/>
+        </p:nvSpPr>
+        <p:spPr>
+          <a:xfrm>
+            <a:off x="493776" y="5769864"/>
+            <a:ext cx="4572000" cy="256032"/>
+          </a:xfrm>
+          <a:prstGeom prst="rect">
+            <a:avLst/>
+          </a:prstGeom>
+          <a:noFill/>
+        </p:spPr>
+        <p:txBody>
+          <a:bodyPr wrap="square">
+            <a:spAutoFit/>
+          </a:bodyPr>
+          <a:lstStyle/>
+          <a:p>
+            <a:pPr algn="l"/>
+            <a:r>
+              <a:rPr b="0" i="0" sz="1000">
+                <a:solidFill>
+                  <a:srgbClr val="1E293B"/>
+                </a:solidFill>
+              </a:rPr>
+              <a:t>Asha Jyothi Boddu  &amp;  Sai Srinidhi Repala</a:t>
             </a:r>
           </a:p>
         </p:txBody>

</xml_diff>